<commit_message>
slides: insert TL;DR (end-user + developer paths) as slides 2-3 in iSideload deck
Co-Authored-By: Claude Opus 4.8 <noreply@anthropic.com>
</commit_message>
<xml_diff>
--- a/docs/iSideload.pptx
+++ b/docs/iSideload.pptx
@@ -6,6 +6,8 @@
   </p:sldMasterIdLst>
   <p:sldIdLst>
     <p:sldId id="256" r:id="rId2"/>
+    <p:sldId id="265" r:id="rId16"/>
+    <p:sldId id="266" r:id="rId17"/>
     <p:sldId id="257" r:id="rId3"/>
     <p:sldId id="258" r:id="rId4"/>
     <p:sldId id="259" r:id="rId5"/>
@@ -2093,6 +2095,830 @@
               <a:t>Current state · July 2026</a:t>
             </a:r>
             <a:endParaRPr lang="en-US" sz="1300" dirty="0"/>
+          </a:p>
+        </p:txBody>
+      </p:sp>
+    </p:spTree>
+  </p:cSld>
+  <p:clrMapOvr>
+    <a:masterClrMapping/>
+  </p:clrMapOvr>
+</p:sld>
+</file>
+
+<file path=ppt/slides/slide10.xml><?xml version="1.0" encoding="utf-8"?>
+<p:sld xmlns:a="http://schemas.openxmlformats.org/drawingml/2006/main" xmlns:p="http://schemas.openxmlformats.org/presentationml/2006/main" xmlns:r="http://schemas.openxmlformats.org/officeDocument/2006/relationships">
+  <p:cSld>
+    <p:spTree>
+      <p:nvGrpSpPr>
+        <p:cNvPr id="1" name=""/>
+        <p:cNvGrpSpPr/>
+        <p:nvPr/>
+      </p:nvGrpSpPr>
+      <p:grpSpPr/>
+      <p:sp>
+        <p:nvSpPr>
+          <p:cNvPr id="2" name="Rectangle 1"/>
+          <p:cNvSpPr/>
+          <p:nvPr/>
+        </p:nvSpPr>
+        <p:spPr>
+          <a:xfrm>
+            <a:off x="0" y="0"/>
+            <a:ext cx="12192000" cy="6858000"/>
+          </a:xfrm>
+          <a:prstGeom prst="rect">
+            <a:avLst/>
+          </a:prstGeom>
+          <a:solidFill>
+            <a:srgbClr val="16232F"/>
+          </a:solidFill>
+          <a:ln>
+            <a:noFill/>
+          </a:ln>
+          <a:effectLst/>
+        </p:spPr>
+        <p:style>
+          <a:lnRef idx="1">
+            <a:schemeClr val="accent1"/>
+          </a:lnRef>
+          <a:fillRef idx="3">
+            <a:schemeClr val="accent1"/>
+          </a:fillRef>
+          <a:effectRef idx="2">
+            <a:schemeClr val="accent1"/>
+          </a:effectRef>
+          <a:fontRef idx="minor">
+            <a:schemeClr val="lt1"/>
+          </a:fontRef>
+        </p:style>
+        <p:txBody>
+          <a:bodyPr rtlCol="0" anchor="ctr"/>
+          <a:lstStyle/>
+          <a:p>
+            <a:pPr algn="ctr"/>
+          </a:p>
+        </p:txBody>
+      </p:sp>
+      <p:sp>
+        <p:nvSpPr>
+          <p:cNvPr id="3" name="TextBox 2"/>
+          <p:cNvSpPr txBox="1"/>
+          <p:nvPr/>
+        </p:nvSpPr>
+        <p:spPr>
+          <a:xfrm>
+            <a:off x="566928" y="457200"/>
+            <a:ext cx="11064240" cy="457200"/>
+          </a:xfrm>
+          <a:prstGeom prst="rect">
+            <a:avLst/>
+          </a:prstGeom>
+          <a:noFill/>
+        </p:spPr>
+        <p:txBody>
+          <a:bodyPr wrap="square" anchor="t" lIns="0" rIns="0" tIns="0" bIns="0">
+            <a:spAutoFit/>
+          </a:bodyPr>
+          <a:lstStyle/>
+          <a:p>
+            <a:r>
+              <a:rPr sz="1500" b="1" i="0">
+                <a:solidFill>
+                  <a:srgbClr val="22C1B6"/>
+                </a:solidFill>
+                <a:latin typeface="Calibri"/>
+              </a:rPr>
+              <a:t>TL;DR  ·  FOR END USERS</a:t>
+            </a:r>
+          </a:p>
+        </p:txBody>
+      </p:sp>
+      <p:sp>
+        <p:nvSpPr>
+          <p:cNvPr id="4" name="TextBox 3"/>
+          <p:cNvSpPr txBox="1"/>
+          <p:nvPr/>
+        </p:nvSpPr>
+        <p:spPr>
+          <a:xfrm>
+            <a:off x="566928" y="868680"/>
+            <a:ext cx="11064240" cy="914400"/>
+          </a:xfrm>
+          <a:prstGeom prst="rect">
+            <a:avLst/>
+          </a:prstGeom>
+          <a:noFill/>
+        </p:spPr>
+        <p:txBody>
+          <a:bodyPr wrap="square" anchor="t" lIns="0" rIns="0" tIns="0" bIns="0">
+            <a:spAutoFit/>
+          </a:bodyPr>
+          <a:lstStyle/>
+          <a:p>
+            <a:r>
+              <a:rPr sz="3400" b="1" i="0">
+                <a:solidFill>
+                  <a:srgbClr val="FFFFFF"/>
+                </a:solidFill>
+                <a:latin typeface="Calibri"/>
+              </a:rPr>
+              <a:t>You can fairly side-load an iOS app</a:t>
+            </a:r>
+          </a:p>
+        </p:txBody>
+      </p:sp>
+      <p:sp>
+        <p:nvSpPr>
+          <p:cNvPr id="5" name="TextBox 4"/>
+          <p:cNvSpPr txBox="1"/>
+          <p:nvPr/>
+        </p:nvSpPr>
+        <p:spPr>
+          <a:xfrm>
+            <a:off x="566928" y="1783080"/>
+            <a:ext cx="11064240" cy="457200"/>
+          </a:xfrm>
+          <a:prstGeom prst="rect">
+            <a:avLst/>
+          </a:prstGeom>
+          <a:noFill/>
+        </p:spPr>
+        <p:txBody>
+          <a:bodyPr wrap="square" anchor="t" lIns="0" rIns="0" tIns="0" bIns="0">
+            <a:spAutoFit/>
+          </a:bodyPr>
+          <a:lstStyle/>
+          <a:p>
+            <a:r>
+              <a:rPr sz="1700" b="0" i="0">
+                <a:solidFill>
+                  <a:srgbClr val="9FB0BE"/>
+                </a:solidFill>
+                <a:latin typeface="Calibri"/>
+              </a:rPr>
+              <a:t>How easily depends on the app developer. Three paths:</a:t>
+            </a:r>
+          </a:p>
+        </p:txBody>
+      </p:sp>
+      <p:sp>
+        <p:nvSpPr>
+          <p:cNvPr id="6" name="Rounded Rectangle 5"/>
+          <p:cNvSpPr/>
+          <p:nvPr/>
+        </p:nvSpPr>
+        <p:spPr>
+          <a:xfrm>
+            <a:off x="566928" y="2468880"/>
+            <a:ext cx="11064240" cy="1051560"/>
+          </a:xfrm>
+          <a:prstGeom prst="roundRect">
+            <a:avLst>
+              <a:gd name="adj" fmla="val 4500"/>
+            </a:avLst>
+          </a:prstGeom>
+          <a:solidFill>
+            <a:srgbClr val="1E3040"/>
+          </a:solidFill>
+          <a:ln>
+            <a:noFill/>
+          </a:ln>
+          <a:effectLst/>
+        </p:spPr>
+        <p:style>
+          <a:lnRef idx="1">
+            <a:schemeClr val="accent1"/>
+          </a:lnRef>
+          <a:fillRef idx="3">
+            <a:schemeClr val="accent1"/>
+          </a:fillRef>
+          <a:effectRef idx="2">
+            <a:schemeClr val="accent1"/>
+          </a:effectRef>
+          <a:fontRef idx="minor">
+            <a:schemeClr val="lt1"/>
+          </a:fontRef>
+        </p:style>
+        <p:txBody>
+          <a:bodyPr rtlCol="0" anchor="ctr" wrap="square" lIns="256032" rIns="256032" tIns="109728" bIns="109728"/>
+          <a:lstStyle/>
+          <a:p>
+            <a:pPr algn="l"/>
+            <a:r>
+              <a:rPr sz="1600" b="1" i="0">
+                <a:solidFill>
+                  <a:srgbClr val="E8A33D"/>
+                </a:solidFill>
+                <a:latin typeface="Calibri"/>
+              </a:rPr>
+              <a:t>★  </a:t>
+            </a:r>
+            <a:r>
+              <a:rPr sz="1700" b="1" i="0">
+                <a:solidFill>
+                  <a:srgbClr val="FFFFFF"/>
+                </a:solidFill>
+                <a:latin typeface="Calibri"/>
+              </a:rPr>
+              <a:t>Easiest — you pay Apple $99/year</a:t>
+            </a:r>
+          </a:p>
+          <a:p>
+            <a:pPr algn="l">
+              <a:spcBef>
+                <a:spcPts val="300"/>
+              </a:spcBef>
+            </a:pPr>
+            <a:r>
+              <a:rPr sz="1400" b="0" i="0">
+                <a:solidFill>
+                  <a:srgbClr val="9FB0BE"/>
+                </a:solidFill>
+                <a:latin typeface="Calibri"/>
+              </a:rPr>
+              <a:t>Sideload unlimited apps to your own devices. You just refresh the installs once a year.</a:t>
+            </a:r>
+          </a:p>
+        </p:txBody>
+      </p:sp>
+      <p:sp>
+        <p:nvSpPr>
+          <p:cNvPr id="7" name="Rounded Rectangle 6"/>
+          <p:cNvSpPr/>
+          <p:nvPr/>
+        </p:nvSpPr>
+        <p:spPr>
+          <a:xfrm>
+            <a:off x="566928" y="3675888"/>
+            <a:ext cx="11064240" cy="1051560"/>
+          </a:xfrm>
+          <a:prstGeom prst="roundRect">
+            <a:avLst>
+              <a:gd name="adj" fmla="val 4500"/>
+            </a:avLst>
+          </a:prstGeom>
+          <a:solidFill>
+            <a:srgbClr val="1E3040"/>
+          </a:solidFill>
+          <a:ln>
+            <a:noFill/>
+          </a:ln>
+          <a:effectLst/>
+        </p:spPr>
+        <p:style>
+          <a:lnRef idx="1">
+            <a:schemeClr val="accent1"/>
+          </a:lnRef>
+          <a:fillRef idx="3">
+            <a:schemeClr val="accent1"/>
+          </a:fillRef>
+          <a:effectRef idx="2">
+            <a:schemeClr val="accent1"/>
+          </a:effectRef>
+          <a:fontRef idx="minor">
+            <a:schemeClr val="lt1"/>
+          </a:fontRef>
+        </p:style>
+        <p:txBody>
+          <a:bodyPr rtlCol="0" anchor="ctr" wrap="square" lIns="256032" rIns="256032" tIns="109728" bIns="109728"/>
+          <a:lstStyle/>
+          <a:p>
+            <a:pPr algn="l"/>
+            <a:r>
+              <a:rPr sz="1600" b="1" i="0">
+                <a:solidFill>
+                  <a:srgbClr val="22C1B6"/>
+                </a:solidFill>
+                <a:latin typeface="Calibri"/>
+              </a:rPr>
+              <a:t>•  </a:t>
+            </a:r>
+            <a:r>
+              <a:rPr sz="1700" b="1" i="0">
+                <a:solidFill>
+                  <a:srgbClr val="FFFFFF"/>
+                </a:solidFill>
+                <a:latin typeface="Calibri"/>
+              </a:rPr>
+              <a:t>Free path — the developer didn't pay Apple either</a:t>
+            </a:r>
+          </a:p>
+          <a:p>
+            <a:pPr algn="l">
+              <a:spcBef>
+                <a:spcPts val="300"/>
+              </a:spcBef>
+            </a:pPr>
+            <a:r>
+              <a:rPr sz="1400" b="0" i="0">
+                <a:solidFill>
+                  <a:srgbClr val="9FB0BE"/>
+                </a:solidFill>
+                <a:latin typeface="Calibri"/>
+              </a:rPr>
+              <a:t>Put your iPhone/iPad into Developer Mode (Settings), trust the key, and install over USB from a Mac.</a:t>
+            </a:r>
+          </a:p>
+        </p:txBody>
+      </p:sp>
+      <p:sp>
+        <p:nvSpPr>
+          <p:cNvPr id="8" name="Rounded Rectangle 7"/>
+          <p:cNvSpPr/>
+          <p:nvPr/>
+        </p:nvSpPr>
+        <p:spPr>
+          <a:xfrm>
+            <a:off x="566928" y="4882896"/>
+            <a:ext cx="11064240" cy="1051560"/>
+          </a:xfrm>
+          <a:prstGeom prst="roundRect">
+            <a:avLst>
+              <a:gd name="adj" fmla="val 4500"/>
+            </a:avLst>
+          </a:prstGeom>
+          <a:solidFill>
+            <a:srgbClr val="1E3040"/>
+          </a:solidFill>
+          <a:ln>
+            <a:noFill/>
+          </a:ln>
+          <a:effectLst/>
+        </p:spPr>
+        <p:style>
+          <a:lnRef idx="1">
+            <a:schemeClr val="accent1"/>
+          </a:lnRef>
+          <a:fillRef idx="3">
+            <a:schemeClr val="accent1"/>
+          </a:fillRef>
+          <a:effectRef idx="2">
+            <a:schemeClr val="accent1"/>
+          </a:effectRef>
+          <a:fontRef idx="minor">
+            <a:schemeClr val="lt1"/>
+          </a:fontRef>
+        </p:style>
+        <p:txBody>
+          <a:bodyPr rtlCol="0" anchor="ctr" wrap="square" lIns="256032" rIns="256032" tIns="109728" bIns="109728"/>
+          <a:lstStyle/>
+          <a:p>
+            <a:pPr algn="l"/>
+            <a:r>
+              <a:rPr sz="1600" b="1" i="0">
+                <a:solidFill>
+                  <a:srgbClr val="22C1B6"/>
+                </a:solidFill>
+                <a:latin typeface="Calibri"/>
+              </a:rPr>
+              <a:t>•  </a:t>
+            </a:r>
+            <a:r>
+              <a:rPr sz="1700" b="1" i="0">
+                <a:solidFill>
+                  <a:srgbClr val="FFFFFF"/>
+                </a:solidFill>
+                <a:latin typeface="Calibri"/>
+              </a:rPr>
+              <a:t>Free path — the developer paid Apple $99</a:t>
+            </a:r>
+          </a:p>
+          <a:p>
+            <a:pPr algn="l">
+              <a:spcBef>
+                <a:spcPts val="300"/>
+              </a:spcBef>
+            </a:pPr>
+            <a:r>
+              <a:rPr sz="1400" b="0" i="0">
+                <a:solidFill>
+                  <a:srgbClr val="9FB0BE"/>
+                </a:solidFill>
+                <a:latin typeface="Calibri"/>
+              </a:rPr>
+              <a:t>Install via a QR code this app shows you — nothing to do to your device. Capped at 100 devices worldwide, so it's best for smaller-audience apps.</a:t>
+            </a:r>
+          </a:p>
+        </p:txBody>
+      </p:sp>
+    </p:spTree>
+  </p:cSld>
+  <p:clrMapOvr>
+    <a:masterClrMapping/>
+  </p:clrMapOvr>
+</p:sld>
+</file>
+
+<file path=ppt/slides/slide11.xml><?xml version="1.0" encoding="utf-8"?>
+<p:sld xmlns:a="http://schemas.openxmlformats.org/drawingml/2006/main" xmlns:p="http://schemas.openxmlformats.org/presentationml/2006/main" xmlns:r="http://schemas.openxmlformats.org/officeDocument/2006/relationships">
+  <p:cSld>
+    <p:spTree>
+      <p:nvGrpSpPr>
+        <p:cNvPr id="1" name=""/>
+        <p:cNvGrpSpPr/>
+        <p:nvPr/>
+      </p:nvGrpSpPr>
+      <p:grpSpPr/>
+      <p:sp>
+        <p:nvSpPr>
+          <p:cNvPr id="2" name="Rectangle 1"/>
+          <p:cNvSpPr/>
+          <p:nvPr/>
+        </p:nvSpPr>
+        <p:spPr>
+          <a:xfrm>
+            <a:off x="0" y="0"/>
+            <a:ext cx="12192000" cy="6858000"/>
+          </a:xfrm>
+          <a:prstGeom prst="rect">
+            <a:avLst/>
+          </a:prstGeom>
+          <a:solidFill>
+            <a:srgbClr val="16232F"/>
+          </a:solidFill>
+          <a:ln>
+            <a:noFill/>
+          </a:ln>
+          <a:effectLst/>
+        </p:spPr>
+        <p:style>
+          <a:lnRef idx="1">
+            <a:schemeClr val="accent1"/>
+          </a:lnRef>
+          <a:fillRef idx="3">
+            <a:schemeClr val="accent1"/>
+          </a:fillRef>
+          <a:effectRef idx="2">
+            <a:schemeClr val="accent1"/>
+          </a:effectRef>
+          <a:fontRef idx="minor">
+            <a:schemeClr val="lt1"/>
+          </a:fontRef>
+        </p:style>
+        <p:txBody>
+          <a:bodyPr rtlCol="0" anchor="ctr"/>
+          <a:lstStyle/>
+          <a:p>
+            <a:pPr algn="ctr"/>
+          </a:p>
+        </p:txBody>
+      </p:sp>
+      <p:sp>
+        <p:nvSpPr>
+          <p:cNvPr id="3" name="TextBox 2"/>
+          <p:cNvSpPr txBox="1"/>
+          <p:nvPr/>
+        </p:nvSpPr>
+        <p:spPr>
+          <a:xfrm>
+            <a:off x="566928" y="457200"/>
+            <a:ext cx="11064240" cy="457200"/>
+          </a:xfrm>
+          <a:prstGeom prst="rect">
+            <a:avLst/>
+          </a:prstGeom>
+          <a:noFill/>
+        </p:spPr>
+        <p:txBody>
+          <a:bodyPr wrap="square" anchor="t" lIns="0" rIns="0" tIns="0" bIns="0">
+            <a:spAutoFit/>
+          </a:bodyPr>
+          <a:lstStyle/>
+          <a:p>
+            <a:r>
+              <a:rPr sz="1500" b="1" i="0">
+                <a:solidFill>
+                  <a:srgbClr val="22C1B6"/>
+                </a:solidFill>
+                <a:latin typeface="Calibri"/>
+              </a:rPr>
+              <a:t>TL;DR  ·  FOR DEVELOPERS</a:t>
+            </a:r>
+          </a:p>
+        </p:txBody>
+      </p:sp>
+      <p:sp>
+        <p:nvSpPr>
+          <p:cNvPr id="4" name="TextBox 3"/>
+          <p:cNvSpPr txBox="1"/>
+          <p:nvPr/>
+        </p:nvSpPr>
+        <p:spPr>
+          <a:xfrm>
+            <a:off x="566928" y="868680"/>
+            <a:ext cx="11064240" cy="914400"/>
+          </a:xfrm>
+          <a:prstGeom prst="rect">
+            <a:avLst/>
+          </a:prstGeom>
+          <a:noFill/>
+        </p:spPr>
+        <p:txBody>
+          <a:bodyPr wrap="square" anchor="t" lIns="0" rIns="0" tIns="0" bIns="0">
+            <a:spAutoFit/>
+          </a:bodyPr>
+          <a:lstStyle/>
+          <a:p>
+            <a:r>
+              <a:rPr sz="3400" b="1" i="0">
+                <a:solidFill>
+                  <a:srgbClr val="FFFFFF"/>
+                </a:solidFill>
+                <a:latin typeface="Calibri"/>
+              </a:rPr>
+              <a:t>How your users install your app</a:t>
+            </a:r>
+          </a:p>
+        </p:txBody>
+      </p:sp>
+      <p:sp>
+        <p:nvSpPr>
+          <p:cNvPr id="5" name="TextBox 4"/>
+          <p:cNvSpPr txBox="1"/>
+          <p:nvPr/>
+        </p:nvSpPr>
+        <p:spPr>
+          <a:xfrm>
+            <a:off x="566928" y="1783080"/>
+            <a:ext cx="11064240" cy="457200"/>
+          </a:xfrm>
+          <a:prstGeom prst="rect">
+            <a:avLst/>
+          </a:prstGeom>
+          <a:noFill/>
+        </p:spPr>
+        <p:txBody>
+          <a:bodyPr wrap="square" anchor="t" lIns="0" rIns="0" tIns="0" bIns="0">
+            <a:spAutoFit/>
+          </a:bodyPr>
+          <a:lstStyle/>
+          <a:p>
+            <a:r>
+              <a:rPr sz="1700" b="0" i="0">
+                <a:solidFill>
+                  <a:srgbClr val="9FB0BE"/>
+                </a:solidFill>
+                <a:latin typeface="Calibri"/>
+              </a:rPr>
+              <a:t>Two ways to ship — pick based on audience size:</a:t>
+            </a:r>
+          </a:p>
+        </p:txBody>
+      </p:sp>
+      <p:sp>
+        <p:nvSpPr>
+          <p:cNvPr id="6" name="Rounded Rectangle 5"/>
+          <p:cNvSpPr/>
+          <p:nvPr/>
+        </p:nvSpPr>
+        <p:spPr>
+          <a:xfrm>
+            <a:off x="566928" y="2514600"/>
+            <a:ext cx="5358384" cy="3291840"/>
+          </a:xfrm>
+          <a:prstGeom prst="roundRect">
+            <a:avLst>
+              <a:gd name="adj" fmla="val 4500"/>
+            </a:avLst>
+          </a:prstGeom>
+          <a:solidFill>
+            <a:srgbClr val="1E3040"/>
+          </a:solidFill>
+          <a:ln>
+            <a:noFill/>
+          </a:ln>
+          <a:effectLst/>
+        </p:spPr>
+        <p:style>
+          <a:lnRef idx="1">
+            <a:schemeClr val="accent1"/>
+          </a:lnRef>
+          <a:fillRef idx="3">
+            <a:schemeClr val="accent1"/>
+          </a:fillRef>
+          <a:effectRef idx="2">
+            <a:schemeClr val="accent1"/>
+          </a:effectRef>
+          <a:fontRef idx="minor">
+            <a:schemeClr val="lt1"/>
+          </a:fontRef>
+        </p:style>
+        <p:txBody>
+          <a:bodyPr rtlCol="0" anchor="ctr"/>
+          <a:lstStyle/>
+          <a:p>
+            <a:pPr algn="ctr"/>
+          </a:p>
+        </p:txBody>
+      </p:sp>
+      <p:sp>
+        <p:nvSpPr>
+          <p:cNvPr id="7" name="TextBox 6"/>
+          <p:cNvSpPr txBox="1"/>
+          <p:nvPr/>
+        </p:nvSpPr>
+        <p:spPr>
+          <a:xfrm>
+            <a:off x="859536" y="2788920"/>
+            <a:ext cx="4773168" cy="2834640"/>
+          </a:xfrm>
+          <a:prstGeom prst="rect">
+            <a:avLst/>
+          </a:prstGeom>
+          <a:noFill/>
+        </p:spPr>
+        <p:txBody>
+          <a:bodyPr wrap="square" anchor="t" lIns="0" rIns="0" tIns="0" bIns="0">
+            <a:spAutoFit/>
+          </a:bodyPr>
+          <a:lstStyle/>
+          <a:p>
+            <a:r>
+              <a:rPr sz="1400" b="1" i="0">
+                <a:solidFill>
+                  <a:srgbClr val="22C1B6"/>
+                </a:solidFill>
+                <a:latin typeface="Calibri"/>
+              </a:rPr>
+              <a:t>OPTION 1</a:t>
+            </a:r>
+          </a:p>
+          <a:p>
+            <a:pPr>
+              <a:spcBef>
+                <a:spcPts val="600"/>
+              </a:spcBef>
+            </a:pPr>
+            <a:r>
+              <a:rPr sz="2200" b="1" i="0">
+                <a:solidFill>
+                  <a:srgbClr val="FFFFFF"/>
+                </a:solidFill>
+                <a:latin typeface="Calibri"/>
+              </a:rPr>
+              <a:t>Free Apple ID</a:t>
+            </a:r>
+          </a:p>
+          <a:p>
+            <a:pPr>
+              <a:spcBef>
+                <a:spcPts val="1000"/>
+              </a:spcBef>
+            </a:pPr>
+            <a:r>
+              <a:rPr sz="1500" b="0" i="0">
+                <a:solidFill>
+                  <a:srgbClr val="9FB0BE"/>
+                </a:solidFill>
+                <a:latin typeface="Calibri"/>
+              </a:rPr>
+              <a:t>Your users log into their own free Apple account, enable Developer Mode, trust the key, and install your .ipa over USB from their Mac. It refreshes every 7 days — or yearly if they have a paid $99 Apple ID.</a:t>
+            </a:r>
+          </a:p>
+          <a:p>
+            <a:pPr>
+              <a:spcBef>
+                <a:spcPts val="1400"/>
+              </a:spcBef>
+            </a:pPr>
+            <a:r>
+              <a:rPr sz="1600" b="1" i="0">
+                <a:solidFill>
+                  <a:srgbClr val="36B37E"/>
+                </a:solidFill>
+                <a:latin typeface="Calibri"/>
+              </a:rPr>
+              <a:t>✓  Unlimited devices</a:t>
+            </a:r>
+          </a:p>
+        </p:txBody>
+      </p:sp>
+      <p:sp>
+        <p:nvSpPr>
+          <p:cNvPr id="8" name="Rounded Rectangle 7"/>
+          <p:cNvSpPr/>
+          <p:nvPr/>
+        </p:nvSpPr>
+        <p:spPr>
+          <a:xfrm>
+            <a:off x="6144768" y="2514600"/>
+            <a:ext cx="5358384" cy="3291840"/>
+          </a:xfrm>
+          <a:prstGeom prst="roundRect">
+            <a:avLst>
+              <a:gd name="adj" fmla="val 4500"/>
+            </a:avLst>
+          </a:prstGeom>
+          <a:solidFill>
+            <a:srgbClr val="22332C"/>
+          </a:solidFill>
+          <a:ln>
+            <a:noFill/>
+          </a:ln>
+          <a:effectLst/>
+        </p:spPr>
+        <p:style>
+          <a:lnRef idx="1">
+            <a:schemeClr val="accent1"/>
+          </a:lnRef>
+          <a:fillRef idx="3">
+            <a:schemeClr val="accent1"/>
+          </a:fillRef>
+          <a:effectRef idx="2">
+            <a:schemeClr val="accent1"/>
+          </a:effectRef>
+          <a:fontRef idx="minor">
+            <a:schemeClr val="lt1"/>
+          </a:fontRef>
+        </p:style>
+        <p:txBody>
+          <a:bodyPr rtlCol="0" anchor="ctr"/>
+          <a:lstStyle/>
+          <a:p>
+            <a:pPr algn="ctr"/>
+          </a:p>
+        </p:txBody>
+      </p:sp>
+      <p:sp>
+        <p:nvSpPr>
+          <p:cNvPr id="9" name="TextBox 8"/>
+          <p:cNvSpPr txBox="1"/>
+          <p:nvPr/>
+        </p:nvSpPr>
+        <p:spPr>
+          <a:xfrm>
+            <a:off x="6437376" y="2788920"/>
+            <a:ext cx="4773168" cy="2834640"/>
+          </a:xfrm>
+          <a:prstGeom prst="rect">
+            <a:avLst/>
+          </a:prstGeom>
+          <a:noFill/>
+        </p:spPr>
+        <p:txBody>
+          <a:bodyPr wrap="square" anchor="t" lIns="0" rIns="0" tIns="0" bIns="0">
+            <a:spAutoFit/>
+          </a:bodyPr>
+          <a:lstStyle/>
+          <a:p>
+            <a:r>
+              <a:rPr sz="1400" b="1" i="0">
+                <a:solidFill>
+                  <a:srgbClr val="E8A33D"/>
+                </a:solidFill>
+                <a:latin typeface="Calibri"/>
+              </a:rPr>
+              <a:t>OPTION 2</a:t>
+            </a:r>
+          </a:p>
+          <a:p>
+            <a:pPr>
+              <a:spcBef>
+                <a:spcPts val="600"/>
+              </a:spcBef>
+            </a:pPr>
+            <a:r>
+              <a:rPr sz="2200" b="1" i="0">
+                <a:solidFill>
+                  <a:srgbClr val="FFFFFF"/>
+                </a:solidFill>
+                <a:latin typeface="Calibri"/>
+              </a:rPr>
+              <a:t>Paid Apple ID + ad-hoc cert</a:t>
+            </a:r>
+          </a:p>
+          <a:p>
+            <a:pPr>
+              <a:spcBef>
+                <a:spcPts val="1000"/>
+              </a:spcBef>
+            </a:pPr>
+            <a:r>
+              <a:rPr sz="1500" b="0" i="0">
+                <a:solidFill>
+                  <a:srgbClr val="9FB0BE"/>
+                </a:solidFill>
+                <a:latin typeface="Calibri"/>
+              </a:rPr>
+              <a:t>You sign your .ipa with an ad-hoc cert. Your users then install via a QR code iSideload creates — and they don't have to do anything else to their device.</a:t>
+            </a:r>
+          </a:p>
+          <a:p>
+            <a:pPr>
+              <a:spcBef>
+                <a:spcPts val="1400"/>
+              </a:spcBef>
+            </a:pPr>
+            <a:r>
+              <a:rPr sz="1600" b="1" i="0">
+                <a:solidFill>
+                  <a:srgbClr val="E8A33D"/>
+                </a:solidFill>
+                <a:latin typeface="Calibri"/>
+              </a:rPr>
+              <a:t>⚠  Limited to 100 devices</a:t>
+            </a:r>
           </a:p>
         </p:txBody>
       </p:sp>

</xml_diff>